<commit_message>
Remove plate assignments from transport plan
Co-Authored-By: Claude Fable 5 <noreply@anthropic.com>
Claude-Session: https://claude.ai/code/session_01PzGxyg7vCW7954f4H7No6N
</commit_message>
<xml_diff>
--- a/תוכנית הובלות 22-23.9.pptx
+++ b/תוכנית הובלות 22-23.9.pptx
@@ -2990,26 +2990,6 @@
             </a:r>
             <a:endParaRPr lang="he-IL" sz="1200" dirty="0"/>
           </a:p>
-          <a:p>
-            <a:pPr algn="r" indent="0" marL="0">
-              <a:spcAft>
-                <a:spcPts val="400"/>
-              </a:spcAft>
-              <a:buNone/>
-            </a:pPr>
-            <a:r>
-              <a:rPr lang="he-IL" altLang="en-US" sz="1050" dirty="0">
-                <a:solidFill>
-                  <a:srgbClr val="262626"/>
-                </a:solidFill>
-                <a:latin typeface="Arial" pitchFamily="34" charset="0"/>
-                <a:ea typeface="Arial" pitchFamily="34" charset="-122"/>
-                <a:cs typeface="Arial" pitchFamily="34" charset="-120"/>
-              </a:rPr>
-              <a:t>• השיבוץ לפלטות לפי סדר הרשימה — ניתן להחליף בין זוגות</a:t>
-            </a:r>
-            <a:endParaRPr lang="he-IL" sz="1200" dirty="0"/>
-          </a:p>
         </p:txBody>
       </p:sp>
       <p:sp>
@@ -3074,10 +3054,9 @@
             <a:tbl>
               <a:tblPr/>
               <a:tblGrid>
-                <a:gridCol w="1600200"/>
-                <a:gridCol w="2286000"/>
-                <a:gridCol w="1234440"/>
-                <a:gridCol w="868680"/>
+                <a:gridCol w="1737360"/>
+                <a:gridCol w="2834640"/>
+                <a:gridCol w="1417320"/>
               </a:tblGrid>
               <a:tr h="217627">
                 <a:tc>
@@ -3284,74 +3263,6 @@
                     </a:solidFill>
                   </a:tcPr>
                 </a:tc>
-                <a:tc>
-                  <a:txBody>
-                    <a:bodyPr/>
-                    <a:lstStyle/>
-                    <a:p>
-                      <a:pPr rtl="1" algn="r" indent="0" marL="0">
-                        <a:buNone/>
-                      </a:pPr>
-                      <a:r>
-                        <a:rPr lang="he-IL" altLang="en-US" sz="1000" b="1" dirty="0">
-                          <a:solidFill>
-                            <a:srgbClr val="FFFFFF"/>
-                          </a:solidFill>
-                          <a:latin typeface="Arial" pitchFamily="34" charset="0"/>
-                          <a:ea typeface="Arial" pitchFamily="34" charset="-122"/>
-                          <a:cs typeface="Arial" pitchFamily="34" charset="-120"/>
-                        </a:rPr>
-                        <a:t>פלטה</a:t>
-                      </a:r>
-                      <a:endParaRPr lang="he-IL" sz="1000" dirty="0">
-                        <a:latin typeface="Arial" charset="0"/>
-                        <a:ea typeface="Arial" charset="0"/>
-                        <a:cs typeface="Arial" charset="0"/>
-                      </a:endParaRPr>
-                    </a:p>
-                  </a:txBody>
-                  <a:tcPr marL="76200" marR="76200" marT="25400" marB="25400" anchor="ctr">
-                    <a:lnL w="6350" cap="flat" cmpd="sng" algn="ctr">
-                      <a:solidFill>
-                        <a:srgbClr val="7E1A1A"/>
-                      </a:solidFill>
-                      <a:prstDash val="solid"/>
-                      <a:round/>
-                      <a:headEnd type="none" w="med" len="med"/>
-                      <a:tailEnd type="none" w="med" len="med"/>
-                    </a:lnL>
-                    <a:lnR w="6350" cap="flat" cmpd="sng" algn="ctr">
-                      <a:solidFill>
-                        <a:srgbClr val="7E1A1A"/>
-                      </a:solidFill>
-                      <a:prstDash val="solid"/>
-                      <a:round/>
-                      <a:headEnd type="none" w="med" len="med"/>
-                      <a:tailEnd type="none" w="med" len="med"/>
-                    </a:lnR>
-                    <a:lnT w="6350" cap="flat" cmpd="sng" algn="ctr">
-                      <a:solidFill>
-                        <a:srgbClr val="7E1A1A"/>
-                      </a:solidFill>
-                      <a:prstDash val="solid"/>
-                      <a:round/>
-                      <a:headEnd type="none" w="med" len="med"/>
-                      <a:tailEnd type="none" w="med" len="med"/>
-                    </a:lnT>
-                    <a:lnB w="6350" cap="flat" cmpd="sng" algn="ctr">
-                      <a:solidFill>
-                        <a:srgbClr val="7E1A1A"/>
-                      </a:solidFill>
-                      <a:prstDash val="solid"/>
-                      <a:round/>
-                      <a:headEnd type="none" w="med" len="med"/>
-                      <a:tailEnd type="none" w="med" len="med"/>
-                    </a:lnB>
-                    <a:solidFill>
-                      <a:srgbClr val="7E1A1A"/>
-                    </a:solidFill>
-                  </a:tcPr>
-                </a:tc>
               </a:tr>
               <a:tr h="217627">
                 <a:tc>
@@ -3538,71 +3449,6 @@
                     </a:lnB>
                   </a:tcPr>
                 </a:tc>
-                <a:tc rowSpan="2">
-                  <a:txBody>
-                    <a:bodyPr/>
-                    <a:lstStyle/>
-                    <a:p>
-                      <a:pPr rtl="1" algn="ctr" indent="0" marL="0">
-                        <a:buNone/>
-                      </a:pPr>
-                      <a:r>
-                        <a:rPr lang="he-IL" altLang="en-US" sz="1100" b="1" dirty="0">
-                          <a:solidFill>
-                            <a:srgbClr val="7E1A1A"/>
-                          </a:solidFill>
-                          <a:latin typeface="Arial" pitchFamily="34" charset="0"/>
-                          <a:ea typeface="Arial" pitchFamily="34" charset="-122"/>
-                          <a:cs typeface="Arial" pitchFamily="34" charset="-120"/>
-                        </a:rPr>
-                        <a:t>1</a:t>
-                      </a:r>
-                      <a:endParaRPr lang="he-IL" sz="1100" dirty="0">
-                        <a:latin typeface="Arial" charset="0"/>
-                        <a:ea typeface="Arial" charset="0"/>
-                        <a:cs typeface="Arial" charset="0"/>
-                      </a:endParaRPr>
-                    </a:p>
-                  </a:txBody>
-                  <a:tcPr marL="76200" marR="76200" marT="25400" marB="25400" anchor="ctr">
-                    <a:lnL w="6350" cap="flat" cmpd="sng" algn="ctr">
-                      <a:solidFill>
-                        <a:srgbClr val="D6CFC9"/>
-                      </a:solidFill>
-                      <a:prstDash val="solid"/>
-                      <a:round/>
-                      <a:headEnd type="none" w="med" len="med"/>
-                      <a:tailEnd type="none" w="med" len="med"/>
-                    </a:lnL>
-                    <a:lnR w="6350" cap="flat" cmpd="sng" algn="ctr">
-                      <a:solidFill>
-                        <a:srgbClr val="D6CFC9"/>
-                      </a:solidFill>
-                      <a:prstDash val="solid"/>
-                      <a:round/>
-                      <a:headEnd type="none" w="med" len="med"/>
-                      <a:tailEnd type="none" w="med" len="med"/>
-                    </a:lnR>
-                    <a:lnT w="6350" cap="flat" cmpd="sng" algn="ctr">
-                      <a:solidFill>
-                        <a:srgbClr val="D6CFC9"/>
-                      </a:solidFill>
-                      <a:prstDash val="solid"/>
-                      <a:round/>
-                      <a:headEnd type="none" w="med" len="med"/>
-                      <a:tailEnd type="none" w="med" len="med"/>
-                    </a:lnT>
-                    <a:lnB w="6350" cap="flat" cmpd="sng" algn="ctr">
-                      <a:solidFill>
-                        <a:srgbClr val="D6CFC9"/>
-                      </a:solidFill>
-                      <a:prstDash val="solid"/>
-                      <a:round/>
-                      <a:headEnd type="none" w="med" len="med"/>
-                      <a:tailEnd type="none" w="med" len="med"/>
-                    </a:lnB>
-                  </a:tcPr>
-                </a:tc>
               </a:tr>
               <a:tr h="217627">
                 <a:tc>
@@ -3668,6 +3514,9 @@
                       <a:headEnd type="none" w="med" len="med"/>
                       <a:tailEnd type="none" w="med" len="med"/>
                     </a:lnB>
+                    <a:solidFill>
+                      <a:srgbClr val="F7F4F2"/>
+                    </a:solidFill>
                   </a:tcPr>
                 </a:tc>
                 <a:tc>
@@ -3733,6 +3582,9 @@
                       <a:headEnd type="none" w="med" len="med"/>
                       <a:tailEnd type="none" w="med" len="med"/>
                     </a:lnB>
+                    <a:solidFill>
+                      <a:srgbClr val="F7F4F2"/>
+                    </a:solidFill>
                   </a:tcPr>
                 </a:tc>
                 <a:tc>
@@ -3798,68 +3650,65 @@
                       <a:headEnd type="none" w="med" len="med"/>
                       <a:tailEnd type="none" w="med" len="med"/>
                     </a:lnB>
-                  </a:tcPr>
-                </a:tc>
-                <a:tc vMerge="1">
-                  <a:tcPr/>
-                </a:tc>
-              </a:tr>
-              <a:tr h="217627">
-                <a:tc>
-                  <a:txBody>
-                    <a:bodyPr/>
-                    <a:lstStyle/>
-                    <a:p>
-                      <a:pPr rtl="1" algn="r" indent="0" marL="0">
-                        <a:buNone/>
-                      </a:pPr>
-                      <a:endParaRPr lang="he-IL" sz="850" dirty="0">
-                        <a:latin typeface="Arial" charset="0"/>
-                        <a:ea typeface="Arial" charset="0"/>
-                        <a:cs typeface="Arial" charset="0"/>
-                      </a:endParaRPr>
-                    </a:p>
-                  </a:txBody>
-                  <a:tcPr marL="76200" marR="76200" marT="25400" marB="25400" anchor="ctr">
-                    <a:lnL w="6350" cap="flat" cmpd="sng" algn="ctr">
-                      <a:solidFill>
-                        <a:srgbClr val="D6CFC9"/>
-                      </a:solidFill>
-                      <a:prstDash val="solid"/>
-                      <a:round/>
-                      <a:headEnd type="none" w="med" len="med"/>
-                      <a:tailEnd type="none" w="med" len="med"/>
-                    </a:lnL>
-                    <a:lnR w="6350" cap="flat" cmpd="sng" algn="ctr">
-                      <a:solidFill>
-                        <a:srgbClr val="D6CFC9"/>
-                      </a:solidFill>
-                      <a:prstDash val="solid"/>
-                      <a:round/>
-                      <a:headEnd type="none" w="med" len="med"/>
-                      <a:tailEnd type="none" w="med" len="med"/>
-                    </a:lnR>
-                    <a:lnT w="6350" cap="flat" cmpd="sng" algn="ctr">
-                      <a:solidFill>
-                        <a:srgbClr val="D6CFC9"/>
-                      </a:solidFill>
-                      <a:prstDash val="solid"/>
-                      <a:round/>
-                      <a:headEnd type="none" w="med" len="med"/>
-                      <a:tailEnd type="none" w="med" len="med"/>
-                    </a:lnT>
-                    <a:lnB w="6350" cap="flat" cmpd="sng" algn="ctr">
-                      <a:solidFill>
-                        <a:srgbClr val="D6CFC9"/>
-                      </a:solidFill>
-                      <a:prstDash val="solid"/>
-                      <a:round/>
-                      <a:headEnd type="none" w="med" len="med"/>
-                      <a:tailEnd type="none" w="med" len="med"/>
-                    </a:lnB>
                     <a:solidFill>
                       <a:srgbClr val="F7F4F2"/>
                     </a:solidFill>
+                  </a:tcPr>
+                </a:tc>
+              </a:tr>
+              <a:tr h="217627">
+                <a:tc>
+                  <a:txBody>
+                    <a:bodyPr/>
+                    <a:lstStyle/>
+                    <a:p>
+                      <a:pPr rtl="1" algn="r" indent="0" marL="0">
+                        <a:buNone/>
+                      </a:pPr>
+                      <a:endParaRPr lang="he-IL" sz="850" dirty="0">
+                        <a:latin typeface="Arial" charset="0"/>
+                        <a:ea typeface="Arial" charset="0"/>
+                        <a:cs typeface="Arial" charset="0"/>
+                      </a:endParaRPr>
+                    </a:p>
+                  </a:txBody>
+                  <a:tcPr marL="76200" marR="76200" marT="25400" marB="25400" anchor="ctr">
+                    <a:lnL w="6350" cap="flat" cmpd="sng" algn="ctr">
+                      <a:solidFill>
+                        <a:srgbClr val="D6CFC9"/>
+                      </a:solidFill>
+                      <a:prstDash val="solid"/>
+                      <a:round/>
+                      <a:headEnd type="none" w="med" len="med"/>
+                      <a:tailEnd type="none" w="med" len="med"/>
+                    </a:lnL>
+                    <a:lnR w="6350" cap="flat" cmpd="sng" algn="ctr">
+                      <a:solidFill>
+                        <a:srgbClr val="D6CFC9"/>
+                      </a:solidFill>
+                      <a:prstDash val="solid"/>
+                      <a:round/>
+                      <a:headEnd type="none" w="med" len="med"/>
+                      <a:tailEnd type="none" w="med" len="med"/>
+                    </a:lnR>
+                    <a:lnT w="6350" cap="flat" cmpd="sng" algn="ctr">
+                      <a:solidFill>
+                        <a:srgbClr val="D6CFC9"/>
+                      </a:solidFill>
+                      <a:prstDash val="solid"/>
+                      <a:round/>
+                      <a:headEnd type="none" w="med" len="med"/>
+                      <a:tailEnd type="none" w="med" len="med"/>
+                    </a:lnT>
+                    <a:lnB w="6350" cap="flat" cmpd="sng" algn="ctr">
+                      <a:solidFill>
+                        <a:srgbClr val="D6CFC9"/>
+                      </a:solidFill>
+                      <a:prstDash val="solid"/>
+                      <a:round/>
+                      <a:headEnd type="none" w="med" len="med"/>
+                      <a:tailEnd type="none" w="med" len="med"/>
+                    </a:lnB>
                   </a:tcPr>
                 </a:tc>
                 <a:tc>
@@ -3925,9 +3774,6 @@
                       <a:headEnd type="none" w="med" len="med"/>
                       <a:tailEnd type="none" w="med" len="med"/>
                     </a:lnB>
-                    <a:solidFill>
-                      <a:srgbClr val="F7F4F2"/>
-                    </a:solidFill>
                   </a:tcPr>
                 </a:tc>
                 <a:tc>
@@ -3993,77 +3839,6 @@
                       <a:headEnd type="none" w="med" len="med"/>
                       <a:tailEnd type="none" w="med" len="med"/>
                     </a:lnB>
-                    <a:solidFill>
-                      <a:srgbClr val="F7F4F2"/>
-                    </a:solidFill>
-                  </a:tcPr>
-                </a:tc>
-                <a:tc rowSpan="2">
-                  <a:txBody>
-                    <a:bodyPr/>
-                    <a:lstStyle/>
-                    <a:p>
-                      <a:pPr rtl="1" algn="ctr" indent="0" marL="0">
-                        <a:buNone/>
-                      </a:pPr>
-                      <a:r>
-                        <a:rPr lang="he-IL" altLang="en-US" sz="1100" b="1" dirty="0">
-                          <a:solidFill>
-                            <a:srgbClr val="7E1A1A"/>
-                          </a:solidFill>
-                          <a:latin typeface="Arial" pitchFamily="34" charset="0"/>
-                          <a:ea typeface="Arial" pitchFamily="34" charset="-122"/>
-                          <a:cs typeface="Arial" pitchFamily="34" charset="-120"/>
-                        </a:rPr>
-                        <a:t>2</a:t>
-                      </a:r>
-                      <a:endParaRPr lang="he-IL" sz="1100" dirty="0">
-                        <a:latin typeface="Arial" charset="0"/>
-                        <a:ea typeface="Arial" charset="0"/>
-                        <a:cs typeface="Arial" charset="0"/>
-                      </a:endParaRPr>
-                    </a:p>
-                  </a:txBody>
-                  <a:tcPr marL="76200" marR="76200" marT="25400" marB="25400" anchor="ctr">
-                    <a:lnL w="6350" cap="flat" cmpd="sng" algn="ctr">
-                      <a:solidFill>
-                        <a:srgbClr val="D6CFC9"/>
-                      </a:solidFill>
-                      <a:prstDash val="solid"/>
-                      <a:round/>
-                      <a:headEnd type="none" w="med" len="med"/>
-                      <a:tailEnd type="none" w="med" len="med"/>
-                    </a:lnL>
-                    <a:lnR w="6350" cap="flat" cmpd="sng" algn="ctr">
-                      <a:solidFill>
-                        <a:srgbClr val="D6CFC9"/>
-                      </a:solidFill>
-                      <a:prstDash val="solid"/>
-                      <a:round/>
-                      <a:headEnd type="none" w="med" len="med"/>
-                      <a:tailEnd type="none" w="med" len="med"/>
-                    </a:lnR>
-                    <a:lnT w="6350" cap="flat" cmpd="sng" algn="ctr">
-                      <a:solidFill>
-                        <a:srgbClr val="D6CFC9"/>
-                      </a:solidFill>
-                      <a:prstDash val="solid"/>
-                      <a:round/>
-                      <a:headEnd type="none" w="med" len="med"/>
-                      <a:tailEnd type="none" w="med" len="med"/>
-                    </a:lnT>
-                    <a:lnB w="6350" cap="flat" cmpd="sng" algn="ctr">
-                      <a:solidFill>
-                        <a:srgbClr val="D6CFC9"/>
-                      </a:solidFill>
-                      <a:prstDash val="solid"/>
-                      <a:round/>
-                      <a:headEnd type="none" w="med" len="med"/>
-                      <a:tailEnd type="none" w="med" len="med"/>
-                    </a:lnB>
-                    <a:solidFill>
-                      <a:srgbClr val="F7F4F2"/>
-                    </a:solidFill>
                   </a:tcPr>
                 </a:tc>
               </a:tr>
@@ -4261,9 +4036,6 @@
                     </a:solidFill>
                   </a:tcPr>
                 </a:tc>
-                <a:tc vMerge="1">
-                  <a:tcPr/>
-                </a:tc>
               </a:tr>
               <a:tr h="217627">
                 <a:tc>
@@ -4450,71 +4222,6 @@
                     </a:lnB>
                   </a:tcPr>
                 </a:tc>
-                <a:tc rowSpan="2">
-                  <a:txBody>
-                    <a:bodyPr/>
-                    <a:lstStyle/>
-                    <a:p>
-                      <a:pPr rtl="1" algn="ctr" indent="0" marL="0">
-                        <a:buNone/>
-                      </a:pPr>
-                      <a:r>
-                        <a:rPr lang="he-IL" altLang="en-US" sz="1100" b="1" dirty="0">
-                          <a:solidFill>
-                            <a:srgbClr val="7E1A1A"/>
-                          </a:solidFill>
-                          <a:latin typeface="Arial" pitchFamily="34" charset="0"/>
-                          <a:ea typeface="Arial" pitchFamily="34" charset="-122"/>
-                          <a:cs typeface="Arial" pitchFamily="34" charset="-120"/>
-                        </a:rPr>
-                        <a:t>3</a:t>
-                      </a:r>
-                      <a:endParaRPr lang="he-IL" sz="1100" dirty="0">
-                        <a:latin typeface="Arial" charset="0"/>
-                        <a:ea typeface="Arial" charset="0"/>
-                        <a:cs typeface="Arial" charset="0"/>
-                      </a:endParaRPr>
-                    </a:p>
-                  </a:txBody>
-                  <a:tcPr marL="76200" marR="76200" marT="25400" marB="25400" anchor="ctr">
-                    <a:lnL w="6350" cap="flat" cmpd="sng" algn="ctr">
-                      <a:solidFill>
-                        <a:srgbClr val="D6CFC9"/>
-                      </a:solidFill>
-                      <a:prstDash val="solid"/>
-                      <a:round/>
-                      <a:headEnd type="none" w="med" len="med"/>
-                      <a:tailEnd type="none" w="med" len="med"/>
-                    </a:lnL>
-                    <a:lnR w="6350" cap="flat" cmpd="sng" algn="ctr">
-                      <a:solidFill>
-                        <a:srgbClr val="D6CFC9"/>
-                      </a:solidFill>
-                      <a:prstDash val="solid"/>
-                      <a:round/>
-                      <a:headEnd type="none" w="med" len="med"/>
-                      <a:tailEnd type="none" w="med" len="med"/>
-                    </a:lnR>
-                    <a:lnT w="6350" cap="flat" cmpd="sng" algn="ctr">
-                      <a:solidFill>
-                        <a:srgbClr val="D6CFC9"/>
-                      </a:solidFill>
-                      <a:prstDash val="solid"/>
-                      <a:round/>
-                      <a:headEnd type="none" w="med" len="med"/>
-                      <a:tailEnd type="none" w="med" len="med"/>
-                    </a:lnT>
-                    <a:lnB w="6350" cap="flat" cmpd="sng" algn="ctr">
-                      <a:solidFill>
-                        <a:srgbClr val="D6CFC9"/>
-                      </a:solidFill>
-                      <a:prstDash val="solid"/>
-                      <a:round/>
-                      <a:headEnd type="none" w="med" len="med"/>
-                      <a:tailEnd type="none" w="med" len="med"/>
-                    </a:lnB>
-                  </a:tcPr>
-                </a:tc>
               </a:tr>
               <a:tr h="217627">
                 <a:tc>
@@ -4569,6 +4276,9 @@
                       <a:headEnd type="none" w="med" len="med"/>
                       <a:tailEnd type="none" w="med" len="med"/>
                     </a:lnB>
+                    <a:solidFill>
+                      <a:srgbClr val="F7F4F2"/>
+                    </a:solidFill>
                   </a:tcPr>
                 </a:tc>
                 <a:tc>
@@ -4634,6 +4344,9 @@
                       <a:headEnd type="none" w="med" len="med"/>
                       <a:tailEnd type="none" w="med" len="med"/>
                     </a:lnB>
+                    <a:solidFill>
+                      <a:srgbClr val="F7F4F2"/>
+                    </a:solidFill>
                   </a:tcPr>
                 </a:tc>
                 <a:tc>
@@ -4699,68 +4412,65 @@
                       <a:headEnd type="none" w="med" len="med"/>
                       <a:tailEnd type="none" w="med" len="med"/>
                     </a:lnB>
-                  </a:tcPr>
-                </a:tc>
-                <a:tc vMerge="1">
-                  <a:tcPr/>
-                </a:tc>
-              </a:tr>
-              <a:tr h="217627">
-                <a:tc>
-                  <a:txBody>
-                    <a:bodyPr/>
-                    <a:lstStyle/>
-                    <a:p>
-                      <a:pPr rtl="1" algn="r" indent="0" marL="0">
-                        <a:buNone/>
-                      </a:pPr>
-                      <a:endParaRPr lang="he-IL" sz="850" dirty="0">
-                        <a:latin typeface="Arial" charset="0"/>
-                        <a:ea typeface="Arial" charset="0"/>
-                        <a:cs typeface="Arial" charset="0"/>
-                      </a:endParaRPr>
-                    </a:p>
-                  </a:txBody>
-                  <a:tcPr marL="76200" marR="76200" marT="25400" marB="25400" anchor="ctr">
-                    <a:lnL w="6350" cap="flat" cmpd="sng" algn="ctr">
-                      <a:solidFill>
-                        <a:srgbClr val="D6CFC9"/>
-                      </a:solidFill>
-                      <a:prstDash val="solid"/>
-                      <a:round/>
-                      <a:headEnd type="none" w="med" len="med"/>
-                      <a:tailEnd type="none" w="med" len="med"/>
-                    </a:lnL>
-                    <a:lnR w="6350" cap="flat" cmpd="sng" algn="ctr">
-                      <a:solidFill>
-                        <a:srgbClr val="D6CFC9"/>
-                      </a:solidFill>
-                      <a:prstDash val="solid"/>
-                      <a:round/>
-                      <a:headEnd type="none" w="med" len="med"/>
-                      <a:tailEnd type="none" w="med" len="med"/>
-                    </a:lnR>
-                    <a:lnT w="6350" cap="flat" cmpd="sng" algn="ctr">
-                      <a:solidFill>
-                        <a:srgbClr val="D6CFC9"/>
-                      </a:solidFill>
-                      <a:prstDash val="solid"/>
-                      <a:round/>
-                      <a:headEnd type="none" w="med" len="med"/>
-                      <a:tailEnd type="none" w="med" len="med"/>
-                    </a:lnT>
-                    <a:lnB w="6350" cap="flat" cmpd="sng" algn="ctr">
-                      <a:solidFill>
-                        <a:srgbClr val="D6CFC9"/>
-                      </a:solidFill>
-                      <a:prstDash val="solid"/>
-                      <a:round/>
-                      <a:headEnd type="none" w="med" len="med"/>
-                      <a:tailEnd type="none" w="med" len="med"/>
-                    </a:lnB>
                     <a:solidFill>
                       <a:srgbClr val="F7F4F2"/>
                     </a:solidFill>
+                  </a:tcPr>
+                </a:tc>
+              </a:tr>
+              <a:tr h="217627">
+                <a:tc>
+                  <a:txBody>
+                    <a:bodyPr/>
+                    <a:lstStyle/>
+                    <a:p>
+                      <a:pPr rtl="1" algn="r" indent="0" marL="0">
+                        <a:buNone/>
+                      </a:pPr>
+                      <a:endParaRPr lang="he-IL" sz="850" dirty="0">
+                        <a:latin typeface="Arial" charset="0"/>
+                        <a:ea typeface="Arial" charset="0"/>
+                        <a:cs typeface="Arial" charset="0"/>
+                      </a:endParaRPr>
+                    </a:p>
+                  </a:txBody>
+                  <a:tcPr marL="76200" marR="76200" marT="25400" marB="25400" anchor="ctr">
+                    <a:lnL w="6350" cap="flat" cmpd="sng" algn="ctr">
+                      <a:solidFill>
+                        <a:srgbClr val="D6CFC9"/>
+                      </a:solidFill>
+                      <a:prstDash val="solid"/>
+                      <a:round/>
+                      <a:headEnd type="none" w="med" len="med"/>
+                      <a:tailEnd type="none" w="med" len="med"/>
+                    </a:lnL>
+                    <a:lnR w="6350" cap="flat" cmpd="sng" algn="ctr">
+                      <a:solidFill>
+                        <a:srgbClr val="D6CFC9"/>
+                      </a:solidFill>
+                      <a:prstDash val="solid"/>
+                      <a:round/>
+                      <a:headEnd type="none" w="med" len="med"/>
+                      <a:tailEnd type="none" w="med" len="med"/>
+                    </a:lnR>
+                    <a:lnT w="6350" cap="flat" cmpd="sng" algn="ctr">
+                      <a:solidFill>
+                        <a:srgbClr val="D6CFC9"/>
+                      </a:solidFill>
+                      <a:prstDash val="solid"/>
+                      <a:round/>
+                      <a:headEnd type="none" w="med" len="med"/>
+                      <a:tailEnd type="none" w="med" len="med"/>
+                    </a:lnT>
+                    <a:lnB w="6350" cap="flat" cmpd="sng" algn="ctr">
+                      <a:solidFill>
+                        <a:srgbClr val="D6CFC9"/>
+                      </a:solidFill>
+                      <a:prstDash val="solid"/>
+                      <a:round/>
+                      <a:headEnd type="none" w="med" len="med"/>
+                      <a:tailEnd type="none" w="med" len="med"/>
+                    </a:lnB>
                   </a:tcPr>
                 </a:tc>
                 <a:tc>
@@ -4826,9 +4536,6 @@
                       <a:headEnd type="none" w="med" len="med"/>
                       <a:tailEnd type="none" w="med" len="med"/>
                     </a:lnB>
-                    <a:solidFill>
-                      <a:srgbClr val="F7F4F2"/>
-                    </a:solidFill>
                   </a:tcPr>
                 </a:tc>
                 <a:tc>
@@ -4894,77 +4601,6 @@
                       <a:headEnd type="none" w="med" len="med"/>
                       <a:tailEnd type="none" w="med" len="med"/>
                     </a:lnB>
-                    <a:solidFill>
-                      <a:srgbClr val="F7F4F2"/>
-                    </a:solidFill>
-                  </a:tcPr>
-                </a:tc>
-                <a:tc rowSpan="2">
-                  <a:txBody>
-                    <a:bodyPr/>
-                    <a:lstStyle/>
-                    <a:p>
-                      <a:pPr rtl="1" algn="ctr" indent="0" marL="0">
-                        <a:buNone/>
-                      </a:pPr>
-                      <a:r>
-                        <a:rPr lang="he-IL" altLang="en-US" sz="1100" b="1" dirty="0">
-                          <a:solidFill>
-                            <a:srgbClr val="7E1A1A"/>
-                          </a:solidFill>
-                          <a:latin typeface="Arial" pitchFamily="34" charset="0"/>
-                          <a:ea typeface="Arial" pitchFamily="34" charset="-122"/>
-                          <a:cs typeface="Arial" pitchFamily="34" charset="-120"/>
-                        </a:rPr>
-                        <a:t>4</a:t>
-                      </a:r>
-                      <a:endParaRPr lang="he-IL" sz="1100" dirty="0">
-                        <a:latin typeface="Arial" charset="0"/>
-                        <a:ea typeface="Arial" charset="0"/>
-                        <a:cs typeface="Arial" charset="0"/>
-                      </a:endParaRPr>
-                    </a:p>
-                  </a:txBody>
-                  <a:tcPr marL="76200" marR="76200" marT="25400" marB="25400" anchor="ctr">
-                    <a:lnL w="6350" cap="flat" cmpd="sng" algn="ctr">
-                      <a:solidFill>
-                        <a:srgbClr val="D6CFC9"/>
-                      </a:solidFill>
-                      <a:prstDash val="solid"/>
-                      <a:round/>
-                      <a:headEnd type="none" w="med" len="med"/>
-                      <a:tailEnd type="none" w="med" len="med"/>
-                    </a:lnL>
-                    <a:lnR w="6350" cap="flat" cmpd="sng" algn="ctr">
-                      <a:solidFill>
-                        <a:srgbClr val="D6CFC9"/>
-                      </a:solidFill>
-                      <a:prstDash val="solid"/>
-                      <a:round/>
-                      <a:headEnd type="none" w="med" len="med"/>
-                      <a:tailEnd type="none" w="med" len="med"/>
-                    </a:lnR>
-                    <a:lnT w="6350" cap="flat" cmpd="sng" algn="ctr">
-                      <a:solidFill>
-                        <a:srgbClr val="D6CFC9"/>
-                      </a:solidFill>
-                      <a:prstDash val="solid"/>
-                      <a:round/>
-                      <a:headEnd type="none" w="med" len="med"/>
-                      <a:tailEnd type="none" w="med" len="med"/>
-                    </a:lnT>
-                    <a:lnB w="6350" cap="flat" cmpd="sng" algn="ctr">
-                      <a:solidFill>
-                        <a:srgbClr val="D6CFC9"/>
-                      </a:solidFill>
-                      <a:prstDash val="solid"/>
-                      <a:round/>
-                      <a:headEnd type="none" w="med" len="med"/>
-                      <a:tailEnd type="none" w="med" len="med"/>
-                    </a:lnB>
-                    <a:solidFill>
-                      <a:srgbClr val="F7F4F2"/>
-                    </a:solidFill>
                   </a:tcPr>
                 </a:tc>
               </a:tr>
@@ -5162,9 +4798,6 @@
                     </a:solidFill>
                   </a:tcPr>
                 </a:tc>
-                <a:tc vMerge="1">
-                  <a:tcPr/>
-                </a:tc>
               </a:tr>
               <a:tr h="217627">
                 <a:tc>
@@ -5351,71 +4984,6 @@
                     </a:lnB>
                   </a:tcPr>
                 </a:tc>
-                <a:tc rowSpan="2">
-                  <a:txBody>
-                    <a:bodyPr/>
-                    <a:lstStyle/>
-                    <a:p>
-                      <a:pPr rtl="1" algn="ctr" indent="0" marL="0">
-                        <a:buNone/>
-                      </a:pPr>
-                      <a:r>
-                        <a:rPr lang="he-IL" altLang="en-US" sz="1100" b="1" dirty="0">
-                          <a:solidFill>
-                            <a:srgbClr val="7E1A1A"/>
-                          </a:solidFill>
-                          <a:latin typeface="Arial" pitchFamily="34" charset="0"/>
-                          <a:ea typeface="Arial" pitchFamily="34" charset="-122"/>
-                          <a:cs typeface="Arial" pitchFamily="34" charset="-120"/>
-                        </a:rPr>
-                        <a:t>5</a:t>
-                      </a:r>
-                      <a:endParaRPr lang="he-IL" sz="1100" dirty="0">
-                        <a:latin typeface="Arial" charset="0"/>
-                        <a:ea typeface="Arial" charset="0"/>
-                        <a:cs typeface="Arial" charset="0"/>
-                      </a:endParaRPr>
-                    </a:p>
-                  </a:txBody>
-                  <a:tcPr marL="76200" marR="76200" marT="25400" marB="25400" anchor="ctr">
-                    <a:lnL w="6350" cap="flat" cmpd="sng" algn="ctr">
-                      <a:solidFill>
-                        <a:srgbClr val="D6CFC9"/>
-                      </a:solidFill>
-                      <a:prstDash val="solid"/>
-                      <a:round/>
-                      <a:headEnd type="none" w="med" len="med"/>
-                      <a:tailEnd type="none" w="med" len="med"/>
-                    </a:lnL>
-                    <a:lnR w="6350" cap="flat" cmpd="sng" algn="ctr">
-                      <a:solidFill>
-                        <a:srgbClr val="D6CFC9"/>
-                      </a:solidFill>
-                      <a:prstDash val="solid"/>
-                      <a:round/>
-                      <a:headEnd type="none" w="med" len="med"/>
-                      <a:tailEnd type="none" w="med" len="med"/>
-                    </a:lnR>
-                    <a:lnT w="6350" cap="flat" cmpd="sng" algn="ctr">
-                      <a:solidFill>
-                        <a:srgbClr val="D6CFC9"/>
-                      </a:solidFill>
-                      <a:prstDash val="solid"/>
-                      <a:round/>
-                      <a:headEnd type="none" w="med" len="med"/>
-                      <a:tailEnd type="none" w="med" len="med"/>
-                    </a:lnT>
-                    <a:lnB w="6350" cap="flat" cmpd="sng" algn="ctr">
-                      <a:solidFill>
-                        <a:srgbClr val="D6CFC9"/>
-                      </a:solidFill>
-                      <a:prstDash val="solid"/>
-                      <a:round/>
-                      <a:headEnd type="none" w="med" len="med"/>
-                      <a:tailEnd type="none" w="med" len="med"/>
-                    </a:lnB>
-                  </a:tcPr>
-                </a:tc>
               </a:tr>
               <a:tr h="217627">
                 <a:tc>
@@ -5470,6 +5038,9 @@
                       <a:headEnd type="none" w="med" len="med"/>
                       <a:tailEnd type="none" w="med" len="med"/>
                     </a:lnB>
+                    <a:solidFill>
+                      <a:srgbClr val="F7F4F2"/>
+                    </a:solidFill>
                   </a:tcPr>
                 </a:tc>
                 <a:tc>
@@ -5535,6 +5106,9 @@
                       <a:headEnd type="none" w="med" len="med"/>
                       <a:tailEnd type="none" w="med" len="med"/>
                     </a:lnB>
+                    <a:solidFill>
+                      <a:srgbClr val="F7F4F2"/>
+                    </a:solidFill>
                   </a:tcPr>
                 </a:tc>
                 <a:tc>
@@ -5600,10 +5174,10 @@
                       <a:headEnd type="none" w="med" len="med"/>
                       <a:tailEnd type="none" w="med" len="med"/>
                     </a:lnB>
-                  </a:tcPr>
-                </a:tc>
-                <a:tc vMerge="1">
-                  <a:tcPr/>
+                    <a:solidFill>
+                      <a:srgbClr val="F7F4F2"/>
+                    </a:solidFill>
+                  </a:tcPr>
                 </a:tc>
               </a:tr>
               <a:tr h="217627">
@@ -5670,9 +5244,6 @@
                       <a:headEnd type="none" w="med" len="med"/>
                       <a:tailEnd type="none" w="med" len="med"/>
                     </a:lnB>
-                    <a:solidFill>
-                      <a:srgbClr val="F7F4F2"/>
-                    </a:solidFill>
                   </a:tcPr>
                 </a:tc>
                 <a:tc>
@@ -5738,9 +5309,6 @@
                       <a:headEnd type="none" w="med" len="med"/>
                       <a:tailEnd type="none" w="med" len="med"/>
                     </a:lnB>
-                    <a:solidFill>
-                      <a:srgbClr val="F7F4F2"/>
-                    </a:solidFill>
                   </a:tcPr>
                 </a:tc>
                 <a:tc>
@@ -5806,77 +5374,6 @@
                       <a:headEnd type="none" w="med" len="med"/>
                       <a:tailEnd type="none" w="med" len="med"/>
                     </a:lnB>
-                    <a:solidFill>
-                      <a:srgbClr val="F7F4F2"/>
-                    </a:solidFill>
-                  </a:tcPr>
-                </a:tc>
-                <a:tc rowSpan="2">
-                  <a:txBody>
-                    <a:bodyPr/>
-                    <a:lstStyle/>
-                    <a:p>
-                      <a:pPr rtl="1" algn="ctr" indent="0" marL="0">
-                        <a:buNone/>
-                      </a:pPr>
-                      <a:r>
-                        <a:rPr lang="he-IL" altLang="en-US" sz="1100" b="1" dirty="0">
-                          <a:solidFill>
-                            <a:srgbClr val="7E1A1A"/>
-                          </a:solidFill>
-                          <a:latin typeface="Arial" pitchFamily="34" charset="0"/>
-                          <a:ea typeface="Arial" pitchFamily="34" charset="-122"/>
-                          <a:cs typeface="Arial" pitchFamily="34" charset="-120"/>
-                        </a:rPr>
-                        <a:t>6</a:t>
-                      </a:r>
-                      <a:endParaRPr lang="he-IL" sz="1100" dirty="0">
-                        <a:latin typeface="Arial" charset="0"/>
-                        <a:ea typeface="Arial" charset="0"/>
-                        <a:cs typeface="Arial" charset="0"/>
-                      </a:endParaRPr>
-                    </a:p>
-                  </a:txBody>
-                  <a:tcPr marL="76200" marR="76200" marT="25400" marB="25400" anchor="ctr">
-                    <a:lnL w="6350" cap="flat" cmpd="sng" algn="ctr">
-                      <a:solidFill>
-                        <a:srgbClr val="D6CFC9"/>
-                      </a:solidFill>
-                      <a:prstDash val="solid"/>
-                      <a:round/>
-                      <a:headEnd type="none" w="med" len="med"/>
-                      <a:tailEnd type="none" w="med" len="med"/>
-                    </a:lnL>
-                    <a:lnR w="6350" cap="flat" cmpd="sng" algn="ctr">
-                      <a:solidFill>
-                        <a:srgbClr val="D6CFC9"/>
-                      </a:solidFill>
-                      <a:prstDash val="solid"/>
-                      <a:round/>
-                      <a:headEnd type="none" w="med" len="med"/>
-                      <a:tailEnd type="none" w="med" len="med"/>
-                    </a:lnR>
-                    <a:lnT w="6350" cap="flat" cmpd="sng" algn="ctr">
-                      <a:solidFill>
-                        <a:srgbClr val="D6CFC9"/>
-                      </a:solidFill>
-                      <a:prstDash val="solid"/>
-                      <a:round/>
-                      <a:headEnd type="none" w="med" len="med"/>
-                      <a:tailEnd type="none" w="med" len="med"/>
-                    </a:lnT>
-                    <a:lnB w="6350" cap="flat" cmpd="sng" algn="ctr">
-                      <a:solidFill>
-                        <a:srgbClr val="D6CFC9"/>
-                      </a:solidFill>
-                      <a:prstDash val="solid"/>
-                      <a:round/>
-                      <a:headEnd type="none" w="med" len="med"/>
-                      <a:tailEnd type="none" w="med" len="med"/>
-                    </a:lnB>
-                    <a:solidFill>
-                      <a:srgbClr val="F7F4F2"/>
-                    </a:solidFill>
                   </a:tcPr>
                 </a:tc>
               </a:tr>
@@ -6085,9 +5582,6 @@
                     </a:solidFill>
                   </a:tcPr>
                 </a:tc>
-                <a:tc vMerge="1">
-                  <a:tcPr/>
-                </a:tc>
               </a:tr>
               <a:tr h="217627">
                 <a:tc>
@@ -6274,71 +5768,6 @@
                     </a:lnB>
                   </a:tcPr>
                 </a:tc>
-                <a:tc rowSpan="2">
-                  <a:txBody>
-                    <a:bodyPr/>
-                    <a:lstStyle/>
-                    <a:p>
-                      <a:pPr rtl="1" algn="ctr" indent="0" marL="0">
-                        <a:buNone/>
-                      </a:pPr>
-                      <a:r>
-                        <a:rPr lang="he-IL" altLang="en-US" sz="1100" b="1" dirty="0">
-                          <a:solidFill>
-                            <a:srgbClr val="7E1A1A"/>
-                          </a:solidFill>
-                          <a:latin typeface="Arial" pitchFamily="34" charset="0"/>
-                          <a:ea typeface="Arial" pitchFamily="34" charset="-122"/>
-                          <a:cs typeface="Arial" pitchFamily="34" charset="-120"/>
-                        </a:rPr>
-                        <a:t>7</a:t>
-                      </a:r>
-                      <a:endParaRPr lang="he-IL" sz="1100" dirty="0">
-                        <a:latin typeface="Arial" charset="0"/>
-                        <a:ea typeface="Arial" charset="0"/>
-                        <a:cs typeface="Arial" charset="0"/>
-                      </a:endParaRPr>
-                    </a:p>
-                  </a:txBody>
-                  <a:tcPr marL="76200" marR="76200" marT="25400" marB="25400" anchor="ctr">
-                    <a:lnL w="6350" cap="flat" cmpd="sng" algn="ctr">
-                      <a:solidFill>
-                        <a:srgbClr val="D6CFC9"/>
-                      </a:solidFill>
-                      <a:prstDash val="solid"/>
-                      <a:round/>
-                      <a:headEnd type="none" w="med" len="med"/>
-                      <a:tailEnd type="none" w="med" len="med"/>
-                    </a:lnL>
-                    <a:lnR w="6350" cap="flat" cmpd="sng" algn="ctr">
-                      <a:solidFill>
-                        <a:srgbClr val="D6CFC9"/>
-                      </a:solidFill>
-                      <a:prstDash val="solid"/>
-                      <a:round/>
-                      <a:headEnd type="none" w="med" len="med"/>
-                      <a:tailEnd type="none" w="med" len="med"/>
-                    </a:lnR>
-                    <a:lnT w="6350" cap="flat" cmpd="sng" algn="ctr">
-                      <a:solidFill>
-                        <a:srgbClr val="D6CFC9"/>
-                      </a:solidFill>
-                      <a:prstDash val="solid"/>
-                      <a:round/>
-                      <a:headEnd type="none" w="med" len="med"/>
-                      <a:tailEnd type="none" w="med" len="med"/>
-                    </a:lnT>
-                    <a:lnB w="6350" cap="flat" cmpd="sng" algn="ctr">
-                      <a:solidFill>
-                        <a:srgbClr val="D6CFC9"/>
-                      </a:solidFill>
-                      <a:prstDash val="solid"/>
-                      <a:round/>
-                      <a:headEnd type="none" w="med" len="med"/>
-                      <a:tailEnd type="none" w="med" len="med"/>
-                    </a:lnB>
-                  </a:tcPr>
-                </a:tc>
               </a:tr>
               <a:tr h="217627">
                 <a:tc>
@@ -6393,6 +5822,9 @@
                       <a:headEnd type="none" w="med" len="med"/>
                       <a:tailEnd type="none" w="med" len="med"/>
                     </a:lnB>
+                    <a:solidFill>
+                      <a:srgbClr val="F7F4F2"/>
+                    </a:solidFill>
                   </a:tcPr>
                 </a:tc>
                 <a:tc>
@@ -6458,6 +5890,9 @@
                       <a:headEnd type="none" w="med" len="med"/>
                       <a:tailEnd type="none" w="med" len="med"/>
                     </a:lnB>
+                    <a:solidFill>
+                      <a:srgbClr val="F7F4F2"/>
+                    </a:solidFill>
                   </a:tcPr>
                 </a:tc>
                 <a:tc>
@@ -6523,68 +5958,65 @@
                       <a:headEnd type="none" w="med" len="med"/>
                       <a:tailEnd type="none" w="med" len="med"/>
                     </a:lnB>
-                  </a:tcPr>
-                </a:tc>
-                <a:tc vMerge="1">
-                  <a:tcPr/>
-                </a:tc>
-              </a:tr>
-              <a:tr h="217627">
-                <a:tc>
-                  <a:txBody>
-                    <a:bodyPr/>
-                    <a:lstStyle/>
-                    <a:p>
-                      <a:pPr rtl="1" algn="r" indent="0" marL="0">
-                        <a:buNone/>
-                      </a:pPr>
-                      <a:endParaRPr lang="he-IL" sz="850" dirty="0">
-                        <a:latin typeface="Arial" charset="0"/>
-                        <a:ea typeface="Arial" charset="0"/>
-                        <a:cs typeface="Arial" charset="0"/>
-                      </a:endParaRPr>
-                    </a:p>
-                  </a:txBody>
-                  <a:tcPr marL="76200" marR="76200" marT="25400" marB="25400" anchor="ctr">
-                    <a:lnL w="6350" cap="flat" cmpd="sng" algn="ctr">
-                      <a:solidFill>
-                        <a:srgbClr val="D6CFC9"/>
-                      </a:solidFill>
-                      <a:prstDash val="solid"/>
-                      <a:round/>
-                      <a:headEnd type="none" w="med" len="med"/>
-                      <a:tailEnd type="none" w="med" len="med"/>
-                    </a:lnL>
-                    <a:lnR w="6350" cap="flat" cmpd="sng" algn="ctr">
-                      <a:solidFill>
-                        <a:srgbClr val="D6CFC9"/>
-                      </a:solidFill>
-                      <a:prstDash val="solid"/>
-                      <a:round/>
-                      <a:headEnd type="none" w="med" len="med"/>
-                      <a:tailEnd type="none" w="med" len="med"/>
-                    </a:lnR>
-                    <a:lnT w="6350" cap="flat" cmpd="sng" algn="ctr">
-                      <a:solidFill>
-                        <a:srgbClr val="D6CFC9"/>
-                      </a:solidFill>
-                      <a:prstDash val="solid"/>
-                      <a:round/>
-                      <a:headEnd type="none" w="med" len="med"/>
-                      <a:tailEnd type="none" w="med" len="med"/>
-                    </a:lnT>
-                    <a:lnB w="6350" cap="flat" cmpd="sng" algn="ctr">
-                      <a:solidFill>
-                        <a:srgbClr val="D6CFC9"/>
-                      </a:solidFill>
-                      <a:prstDash val="solid"/>
-                      <a:round/>
-                      <a:headEnd type="none" w="med" len="med"/>
-                      <a:tailEnd type="none" w="med" len="med"/>
-                    </a:lnB>
                     <a:solidFill>
                       <a:srgbClr val="F7F4F2"/>
                     </a:solidFill>
+                  </a:tcPr>
+                </a:tc>
+              </a:tr>
+              <a:tr h="217627">
+                <a:tc>
+                  <a:txBody>
+                    <a:bodyPr/>
+                    <a:lstStyle/>
+                    <a:p>
+                      <a:pPr rtl="1" algn="r" indent="0" marL="0">
+                        <a:buNone/>
+                      </a:pPr>
+                      <a:endParaRPr lang="he-IL" sz="850" dirty="0">
+                        <a:latin typeface="Arial" charset="0"/>
+                        <a:ea typeface="Arial" charset="0"/>
+                        <a:cs typeface="Arial" charset="0"/>
+                      </a:endParaRPr>
+                    </a:p>
+                  </a:txBody>
+                  <a:tcPr marL="76200" marR="76200" marT="25400" marB="25400" anchor="ctr">
+                    <a:lnL w="6350" cap="flat" cmpd="sng" algn="ctr">
+                      <a:solidFill>
+                        <a:srgbClr val="D6CFC9"/>
+                      </a:solidFill>
+                      <a:prstDash val="solid"/>
+                      <a:round/>
+                      <a:headEnd type="none" w="med" len="med"/>
+                      <a:tailEnd type="none" w="med" len="med"/>
+                    </a:lnL>
+                    <a:lnR w="6350" cap="flat" cmpd="sng" algn="ctr">
+                      <a:solidFill>
+                        <a:srgbClr val="D6CFC9"/>
+                      </a:solidFill>
+                      <a:prstDash val="solid"/>
+                      <a:round/>
+                      <a:headEnd type="none" w="med" len="med"/>
+                      <a:tailEnd type="none" w="med" len="med"/>
+                    </a:lnR>
+                    <a:lnT w="6350" cap="flat" cmpd="sng" algn="ctr">
+                      <a:solidFill>
+                        <a:srgbClr val="D6CFC9"/>
+                      </a:solidFill>
+                      <a:prstDash val="solid"/>
+                      <a:round/>
+                      <a:headEnd type="none" w="med" len="med"/>
+                      <a:tailEnd type="none" w="med" len="med"/>
+                    </a:lnT>
+                    <a:lnB w="6350" cap="flat" cmpd="sng" algn="ctr">
+                      <a:solidFill>
+                        <a:srgbClr val="D6CFC9"/>
+                      </a:solidFill>
+                      <a:prstDash val="solid"/>
+                      <a:round/>
+                      <a:headEnd type="none" w="med" len="med"/>
+                      <a:tailEnd type="none" w="med" len="med"/>
+                    </a:lnB>
                   </a:tcPr>
                 </a:tc>
                 <a:tc>
@@ -6650,9 +6082,6 @@
                       <a:headEnd type="none" w="med" len="med"/>
                       <a:tailEnd type="none" w="med" len="med"/>
                     </a:lnB>
-                    <a:solidFill>
-                      <a:srgbClr val="F7F4F2"/>
-                    </a:solidFill>
                   </a:tcPr>
                 </a:tc>
                 <a:tc>
@@ -6718,77 +6147,6 @@
                       <a:headEnd type="none" w="med" len="med"/>
                       <a:tailEnd type="none" w="med" len="med"/>
                     </a:lnB>
-                    <a:solidFill>
-                      <a:srgbClr val="F7F4F2"/>
-                    </a:solidFill>
-                  </a:tcPr>
-                </a:tc>
-                <a:tc rowSpan="2">
-                  <a:txBody>
-                    <a:bodyPr/>
-                    <a:lstStyle/>
-                    <a:p>
-                      <a:pPr rtl="1" algn="ctr" indent="0" marL="0">
-                        <a:buNone/>
-                      </a:pPr>
-                      <a:r>
-                        <a:rPr lang="he-IL" altLang="en-US" sz="1100" b="1" dirty="0">
-                          <a:solidFill>
-                            <a:srgbClr val="7E1A1A"/>
-                          </a:solidFill>
-                          <a:latin typeface="Arial" pitchFamily="34" charset="0"/>
-                          <a:ea typeface="Arial" pitchFamily="34" charset="-122"/>
-                          <a:cs typeface="Arial" pitchFamily="34" charset="-120"/>
-                        </a:rPr>
-                        <a:t>8</a:t>
-                      </a:r>
-                      <a:endParaRPr lang="he-IL" sz="1100" dirty="0">
-                        <a:latin typeface="Arial" charset="0"/>
-                        <a:ea typeface="Arial" charset="0"/>
-                        <a:cs typeface="Arial" charset="0"/>
-                      </a:endParaRPr>
-                    </a:p>
-                  </a:txBody>
-                  <a:tcPr marL="76200" marR="76200" marT="25400" marB="25400" anchor="ctr">
-                    <a:lnL w="6350" cap="flat" cmpd="sng" algn="ctr">
-                      <a:solidFill>
-                        <a:srgbClr val="D6CFC9"/>
-                      </a:solidFill>
-                      <a:prstDash val="solid"/>
-                      <a:round/>
-                      <a:headEnd type="none" w="med" len="med"/>
-                      <a:tailEnd type="none" w="med" len="med"/>
-                    </a:lnL>
-                    <a:lnR w="6350" cap="flat" cmpd="sng" algn="ctr">
-                      <a:solidFill>
-                        <a:srgbClr val="D6CFC9"/>
-                      </a:solidFill>
-                      <a:prstDash val="solid"/>
-                      <a:round/>
-                      <a:headEnd type="none" w="med" len="med"/>
-                      <a:tailEnd type="none" w="med" len="med"/>
-                    </a:lnR>
-                    <a:lnT w="6350" cap="flat" cmpd="sng" algn="ctr">
-                      <a:solidFill>
-                        <a:srgbClr val="D6CFC9"/>
-                      </a:solidFill>
-                      <a:prstDash val="solid"/>
-                      <a:round/>
-                      <a:headEnd type="none" w="med" len="med"/>
-                      <a:tailEnd type="none" w="med" len="med"/>
-                    </a:lnT>
-                    <a:lnB w="6350" cap="flat" cmpd="sng" algn="ctr">
-                      <a:solidFill>
-                        <a:srgbClr val="D6CFC9"/>
-                      </a:solidFill>
-                      <a:prstDash val="solid"/>
-                      <a:round/>
-                      <a:headEnd type="none" w="med" len="med"/>
-                      <a:tailEnd type="none" w="med" len="med"/>
-                    </a:lnB>
-                    <a:solidFill>
-                      <a:srgbClr val="F7F4F2"/>
-                    </a:solidFill>
                   </a:tcPr>
                 </a:tc>
               </a:tr>
@@ -6986,9 +6344,6 @@
                     </a:solidFill>
                   </a:tcPr>
                 </a:tc>
-                <a:tc vMerge="1">
-                  <a:tcPr/>
-                </a:tc>
               </a:tr>
               <a:tr h="217627">
                 <a:tc>
@@ -7186,71 +6541,6 @@
                     </a:lnB>
                   </a:tcPr>
                 </a:tc>
-                <a:tc rowSpan="2">
-                  <a:txBody>
-                    <a:bodyPr/>
-                    <a:lstStyle/>
-                    <a:p>
-                      <a:pPr rtl="1" algn="ctr" indent="0" marL="0">
-                        <a:buNone/>
-                      </a:pPr>
-                      <a:r>
-                        <a:rPr lang="he-IL" altLang="en-US" sz="1100" b="1" dirty="0">
-                          <a:solidFill>
-                            <a:srgbClr val="7E1A1A"/>
-                          </a:solidFill>
-                          <a:latin typeface="Arial" pitchFamily="34" charset="0"/>
-                          <a:ea typeface="Arial" pitchFamily="34" charset="-122"/>
-                          <a:cs typeface="Arial" pitchFamily="34" charset="-120"/>
-                        </a:rPr>
-                        <a:t>9</a:t>
-                      </a:r>
-                      <a:endParaRPr lang="he-IL" sz="1100" dirty="0">
-                        <a:latin typeface="Arial" charset="0"/>
-                        <a:ea typeface="Arial" charset="0"/>
-                        <a:cs typeface="Arial" charset="0"/>
-                      </a:endParaRPr>
-                    </a:p>
-                  </a:txBody>
-                  <a:tcPr marL="76200" marR="76200" marT="25400" marB="25400" anchor="ctr">
-                    <a:lnL w="6350" cap="flat" cmpd="sng" algn="ctr">
-                      <a:solidFill>
-                        <a:srgbClr val="D6CFC9"/>
-                      </a:solidFill>
-                      <a:prstDash val="solid"/>
-                      <a:round/>
-                      <a:headEnd type="none" w="med" len="med"/>
-                      <a:tailEnd type="none" w="med" len="med"/>
-                    </a:lnL>
-                    <a:lnR w="6350" cap="flat" cmpd="sng" algn="ctr">
-                      <a:solidFill>
-                        <a:srgbClr val="D6CFC9"/>
-                      </a:solidFill>
-                      <a:prstDash val="solid"/>
-                      <a:round/>
-                      <a:headEnd type="none" w="med" len="med"/>
-                      <a:tailEnd type="none" w="med" len="med"/>
-                    </a:lnR>
-                    <a:lnT w="6350" cap="flat" cmpd="sng" algn="ctr">
-                      <a:solidFill>
-                        <a:srgbClr val="D6CFC9"/>
-                      </a:solidFill>
-                      <a:prstDash val="solid"/>
-                      <a:round/>
-                      <a:headEnd type="none" w="med" len="med"/>
-                      <a:tailEnd type="none" w="med" len="med"/>
-                    </a:lnT>
-                    <a:lnB w="6350" cap="flat" cmpd="sng" algn="ctr">
-                      <a:solidFill>
-                        <a:srgbClr val="D6CFC9"/>
-                      </a:solidFill>
-                      <a:prstDash val="solid"/>
-                      <a:round/>
-                      <a:headEnd type="none" w="med" len="med"/>
-                      <a:tailEnd type="none" w="med" len="med"/>
-                    </a:lnB>
-                  </a:tcPr>
-                </a:tc>
               </a:tr>
               <a:tr h="217627">
                 <a:tc>
@@ -7305,6 +6595,9 @@
                       <a:headEnd type="none" w="med" len="med"/>
                       <a:tailEnd type="none" w="med" len="med"/>
                     </a:lnB>
+                    <a:solidFill>
+                      <a:srgbClr val="F7F4F2"/>
+                    </a:solidFill>
                   </a:tcPr>
                 </a:tc>
                 <a:tc>
@@ -7370,6 +6663,9 @@
                       <a:headEnd type="none" w="med" len="med"/>
                       <a:tailEnd type="none" w="med" len="med"/>
                     </a:lnB>
+                    <a:solidFill>
+                      <a:srgbClr val="F7F4F2"/>
+                    </a:solidFill>
                   </a:tcPr>
                 </a:tc>
                 <a:tc>
@@ -7435,68 +6731,65 @@
                       <a:headEnd type="none" w="med" len="med"/>
                       <a:tailEnd type="none" w="med" len="med"/>
                     </a:lnB>
-                  </a:tcPr>
-                </a:tc>
-                <a:tc vMerge="1">
-                  <a:tcPr/>
-                </a:tc>
-              </a:tr>
-              <a:tr h="217627">
-                <a:tc>
-                  <a:txBody>
-                    <a:bodyPr/>
-                    <a:lstStyle/>
-                    <a:p>
-                      <a:pPr rtl="1" algn="r" indent="0" marL="0">
-                        <a:buNone/>
-                      </a:pPr>
-                      <a:endParaRPr lang="he-IL" sz="850" dirty="0">
-                        <a:latin typeface="Arial" charset="0"/>
-                        <a:ea typeface="Arial" charset="0"/>
-                        <a:cs typeface="Arial" charset="0"/>
-                      </a:endParaRPr>
-                    </a:p>
-                  </a:txBody>
-                  <a:tcPr marL="76200" marR="76200" marT="25400" marB="25400" anchor="ctr">
-                    <a:lnL w="6350" cap="flat" cmpd="sng" algn="ctr">
-                      <a:solidFill>
-                        <a:srgbClr val="D6CFC9"/>
-                      </a:solidFill>
-                      <a:prstDash val="solid"/>
-                      <a:round/>
-                      <a:headEnd type="none" w="med" len="med"/>
-                      <a:tailEnd type="none" w="med" len="med"/>
-                    </a:lnL>
-                    <a:lnR w="6350" cap="flat" cmpd="sng" algn="ctr">
-                      <a:solidFill>
-                        <a:srgbClr val="D6CFC9"/>
-                      </a:solidFill>
-                      <a:prstDash val="solid"/>
-                      <a:round/>
-                      <a:headEnd type="none" w="med" len="med"/>
-                      <a:tailEnd type="none" w="med" len="med"/>
-                    </a:lnR>
-                    <a:lnT w="6350" cap="flat" cmpd="sng" algn="ctr">
-                      <a:solidFill>
-                        <a:srgbClr val="D6CFC9"/>
-                      </a:solidFill>
-                      <a:prstDash val="solid"/>
-                      <a:round/>
-                      <a:headEnd type="none" w="med" len="med"/>
-                      <a:tailEnd type="none" w="med" len="med"/>
-                    </a:lnT>
-                    <a:lnB w="6350" cap="flat" cmpd="sng" algn="ctr">
-                      <a:solidFill>
-                        <a:srgbClr val="D6CFC9"/>
-                      </a:solidFill>
-                      <a:prstDash val="solid"/>
-                      <a:round/>
-                      <a:headEnd type="none" w="med" len="med"/>
-                      <a:tailEnd type="none" w="med" len="med"/>
-                    </a:lnB>
                     <a:solidFill>
                       <a:srgbClr val="F7F4F2"/>
                     </a:solidFill>
+                  </a:tcPr>
+                </a:tc>
+              </a:tr>
+              <a:tr h="217627">
+                <a:tc>
+                  <a:txBody>
+                    <a:bodyPr/>
+                    <a:lstStyle/>
+                    <a:p>
+                      <a:pPr rtl="1" algn="r" indent="0" marL="0">
+                        <a:buNone/>
+                      </a:pPr>
+                      <a:endParaRPr lang="he-IL" sz="850" dirty="0">
+                        <a:latin typeface="Arial" charset="0"/>
+                        <a:ea typeface="Arial" charset="0"/>
+                        <a:cs typeface="Arial" charset="0"/>
+                      </a:endParaRPr>
+                    </a:p>
+                  </a:txBody>
+                  <a:tcPr marL="76200" marR="76200" marT="25400" marB="25400" anchor="ctr">
+                    <a:lnL w="6350" cap="flat" cmpd="sng" algn="ctr">
+                      <a:solidFill>
+                        <a:srgbClr val="D6CFC9"/>
+                      </a:solidFill>
+                      <a:prstDash val="solid"/>
+                      <a:round/>
+                      <a:headEnd type="none" w="med" len="med"/>
+                      <a:tailEnd type="none" w="med" len="med"/>
+                    </a:lnL>
+                    <a:lnR w="6350" cap="flat" cmpd="sng" algn="ctr">
+                      <a:solidFill>
+                        <a:srgbClr val="D6CFC9"/>
+                      </a:solidFill>
+                      <a:prstDash val="solid"/>
+                      <a:round/>
+                      <a:headEnd type="none" w="med" len="med"/>
+                      <a:tailEnd type="none" w="med" len="med"/>
+                    </a:lnR>
+                    <a:lnT w="6350" cap="flat" cmpd="sng" algn="ctr">
+                      <a:solidFill>
+                        <a:srgbClr val="D6CFC9"/>
+                      </a:solidFill>
+                      <a:prstDash val="solid"/>
+                      <a:round/>
+                      <a:headEnd type="none" w="med" len="med"/>
+                      <a:tailEnd type="none" w="med" len="med"/>
+                    </a:lnT>
+                    <a:lnB w="6350" cap="flat" cmpd="sng" algn="ctr">
+                      <a:solidFill>
+                        <a:srgbClr val="D6CFC9"/>
+                      </a:solidFill>
+                      <a:prstDash val="solid"/>
+                      <a:round/>
+                      <a:headEnd type="none" w="med" len="med"/>
+                      <a:tailEnd type="none" w="med" len="med"/>
+                    </a:lnB>
                   </a:tcPr>
                 </a:tc>
                 <a:tc>
@@ -7562,9 +6855,6 @@
                       <a:headEnd type="none" w="med" len="med"/>
                       <a:tailEnd type="none" w="med" len="med"/>
                     </a:lnB>
-                    <a:solidFill>
-                      <a:srgbClr val="F7F4F2"/>
-                    </a:solidFill>
                   </a:tcPr>
                 </a:tc>
                 <a:tc>
@@ -7630,77 +6920,6 @@
                       <a:headEnd type="none" w="med" len="med"/>
                       <a:tailEnd type="none" w="med" len="med"/>
                     </a:lnB>
-                    <a:solidFill>
-                      <a:srgbClr val="F7F4F2"/>
-                    </a:solidFill>
-                  </a:tcPr>
-                </a:tc>
-                <a:tc rowSpan="2">
-                  <a:txBody>
-                    <a:bodyPr/>
-                    <a:lstStyle/>
-                    <a:p>
-                      <a:pPr rtl="1" algn="ctr" indent="0" marL="0">
-                        <a:buNone/>
-                      </a:pPr>
-                      <a:r>
-                        <a:rPr lang="he-IL" altLang="en-US" sz="1100" b="1" dirty="0">
-                          <a:solidFill>
-                            <a:srgbClr val="7E1A1A"/>
-                          </a:solidFill>
-                          <a:latin typeface="Arial" pitchFamily="34" charset="0"/>
-                          <a:ea typeface="Arial" pitchFamily="34" charset="-122"/>
-                          <a:cs typeface="Arial" pitchFamily="34" charset="-120"/>
-                        </a:rPr>
-                        <a:t>10</a:t>
-                      </a:r>
-                      <a:endParaRPr lang="he-IL" sz="1100" dirty="0">
-                        <a:latin typeface="Arial" charset="0"/>
-                        <a:ea typeface="Arial" charset="0"/>
-                        <a:cs typeface="Arial" charset="0"/>
-                      </a:endParaRPr>
-                    </a:p>
-                  </a:txBody>
-                  <a:tcPr marL="76200" marR="76200" marT="25400" marB="25400" anchor="ctr">
-                    <a:lnL w="6350" cap="flat" cmpd="sng" algn="ctr">
-                      <a:solidFill>
-                        <a:srgbClr val="D6CFC9"/>
-                      </a:solidFill>
-                      <a:prstDash val="solid"/>
-                      <a:round/>
-                      <a:headEnd type="none" w="med" len="med"/>
-                      <a:tailEnd type="none" w="med" len="med"/>
-                    </a:lnL>
-                    <a:lnR w="6350" cap="flat" cmpd="sng" algn="ctr">
-                      <a:solidFill>
-                        <a:srgbClr val="D6CFC9"/>
-                      </a:solidFill>
-                      <a:prstDash val="solid"/>
-                      <a:round/>
-                      <a:headEnd type="none" w="med" len="med"/>
-                      <a:tailEnd type="none" w="med" len="med"/>
-                    </a:lnR>
-                    <a:lnT w="6350" cap="flat" cmpd="sng" algn="ctr">
-                      <a:solidFill>
-                        <a:srgbClr val="D6CFC9"/>
-                      </a:solidFill>
-                      <a:prstDash val="solid"/>
-                      <a:round/>
-                      <a:headEnd type="none" w="med" len="med"/>
-                      <a:tailEnd type="none" w="med" len="med"/>
-                    </a:lnT>
-                    <a:lnB w="6350" cap="flat" cmpd="sng" algn="ctr">
-                      <a:solidFill>
-                        <a:srgbClr val="D6CFC9"/>
-                      </a:solidFill>
-                      <a:prstDash val="solid"/>
-                      <a:round/>
-                      <a:headEnd type="none" w="med" len="med"/>
-                      <a:tailEnd type="none" w="med" len="med"/>
-                    </a:lnB>
-                    <a:solidFill>
-                      <a:srgbClr val="F7F4F2"/>
-                    </a:solidFill>
                   </a:tcPr>
                 </a:tc>
               </a:tr>
@@ -7897,9 +7116,6 @@
                       <a:srgbClr val="F7F4F2"/>
                     </a:solidFill>
                   </a:tcPr>
-                </a:tc>
-                <a:tc vMerge="1">
-                  <a:tcPr/>
                 </a:tc>
               </a:tr>
             </a:tbl>

</xml_diff>